<commit_message>
Implement Aether Master Dashboard Auto-Scaling Webhook, Aether Pulse Subworkflow, & V3 N8N Credential Watchdog Daemon
</commit_message>
<xml_diff>
--- a/data/executive_reports/Delegate_AI_Investor_Pitch.pptx
+++ b/data/executive_reports/Delegate_AI_Investor_Pitch.pptx
@@ -12,6 +12,7 @@
     <p:sldId id="260" r:id="rId11"/>
     <p:sldId id="261" r:id="rId12"/>
     <p:sldId id="262" r:id="rId13"/>
+    <p:sldId id="263" r:id="rId14"/>
   </p:sldIdLst>
   <p:sldSz cx="12192000" cy="6858000" type="screen4x3"/>
   <p:notesSz cx="6858000" cy="9144000"/>
@@ -3142,7 +3143,7 @@
               </a:defRPr>
             </a:pPr>
             <a:r>
-              <a:t>Antigravity-AI — Investor Brief</a:t>
+              <a:t>Antigravity-AI - Investor Brief</a:t>
             </a:r>
           </a:p>
         </p:txBody>
@@ -3213,7 +3214,7 @@
               </a:defRPr>
             </a:pPr>
             <a:r>
-              <a:t>March 11, 2026</a:t>
+              <a:t>March 17, 2026</a:t>
             </a:r>
           </a:p>
         </p:txBody>
@@ -3323,7 +3324,7 @@
               </a:defRPr>
             </a:pPr>
             <a:r>
-              <a:t>  18-agent autonomous AI network managing trading, analysis, and operations</a:t>
+              <a:t>  18-agent autonomous AI network (V7 Router)</a:t>
             </a:r>
           </a:p>
           <a:p>
@@ -3371,7 +3372,7 @@
               </a:defRPr>
             </a:pPr>
             <a:r>
-              <a:t>  Emotional intelligence layer adapting to operator stress in real-time</a:t>
+              <a:t>  Break-even: Month 2</a:t>
             </a:r>
           </a:p>
           <a:p>
@@ -3458,7 +3459,7 @@
               </a:defRPr>
             </a:pPr>
             <a:r>
-              <a:t>Scalable Architecture</a:t>
+              <a:t>Scalable Agent Architecture</a:t>
             </a:r>
           </a:p>
         </p:txBody>
@@ -3497,7 +3498,7 @@
               </a:defRPr>
             </a:pPr>
             <a:r>
-              <a:t>  V7 Agent Skills Router — 18 specialist agents with load balancing</a:t>
+              <a:t>  V7 Agent Skills Router -&gt; 18 specialist agents</a:t>
             </a:r>
           </a:p>
           <a:p>
@@ -3513,7 +3514,7 @@
               </a:defRPr>
             </a:pPr>
             <a:r>
-              <a:t>  Delegate AI Orchestrator for performance-based task routing</a:t>
+              <a:t>  Delegate AI Orchestrator for performance-based routing</a:t>
             </a:r>
           </a:p>
           <a:p>
@@ -3545,7 +3546,7 @@
               </a:defRPr>
             </a:pPr>
             <a:r>
-              <a:t>  Visual Mapping Protocol for orphaned/bottleneck detection</a:t>
+              <a:t>  DataValidationEngine: Signal Warnings on bad data</a:t>
             </a:r>
           </a:p>
           <a:p>
@@ -3561,7 +3562,7 @@
               </a:defRPr>
             </a:pPr>
             <a:r>
-              <a:t>  Circuit breaker pattern preventing cascade failures</a:t>
+              <a:t>  News Bureau Chief: auto-triggered context refresh</a:t>
             </a:r>
           </a:p>
         </p:txBody>
@@ -3632,110 +3633,7 @@
               </a:defRPr>
             </a:pPr>
             <a:r>
-              <a:t>Market Intelligence (GeoTalent)</a:t>
-            </a:r>
-          </a:p>
-        </p:txBody>
-      </p:sp>
-      <p:sp>
-        <p:nvSpPr>
-          <p:cNvPr id="4" name="TextBox 3"/>
-          <p:cNvSpPr txBox="1"/>
-          <p:nvPr/>
-        </p:nvSpPr>
-        <p:spPr>
-          <a:xfrm>
-            <a:off x="731520" y="1645920"/>
-            <a:ext cx="9144000" cy="4114800"/>
-          </a:xfrm>
-          <a:prstGeom prst="rect">
-            <a:avLst/>
-          </a:prstGeom>
-          <a:noFill/>
-        </p:spPr>
-        <p:txBody>
-          <a:bodyPr wrap="square">
-            <a:spAutoFit/>
-          </a:bodyPr>
-          <a:lstStyle/>
-          <a:p>
-            <a:pPr>
-              <a:spcAft>
-                <a:spcPts val="1000"/>
-              </a:spcAft>
-              <a:defRPr sz="1600">
-                <a:solidFill>
-                  <a:srgbClr val="1E293B"/>
-                </a:solidFill>
-                <a:latin typeface="Roboto"/>
-              </a:defRPr>
-            </a:pPr>
-            <a:r>
-              <a:t>  Skill Gap Analyzer scanning MASTER_INDEX for systemic weaknesses</a:t>
-            </a:r>
-          </a:p>
-          <a:p>
-            <a:pPr>
-              <a:spcAft>
-                <a:spcPts val="1000"/>
-              </a:spcAft>
-              <a:defRPr sz="1600">
-                <a:solidFill>
-                  <a:srgbClr val="1E293B"/>
-                </a:solidFill>
-                <a:latin typeface="Roboto"/>
-              </a:defRPr>
-            </a:pPr>
-            <a:r>
-              <a:t>  Market Trends Monitor tracking 2026 AI standards (LLMs, frameworks)</a:t>
-            </a:r>
-          </a:p>
-          <a:p>
-            <a:pPr>
-              <a:spcAft>
-                <a:spcPts val="1000"/>
-              </a:spcAft>
-              <a:defRPr sz="1600">
-                <a:solidFill>
-                  <a:srgbClr val="1E293B"/>
-                </a:solidFill>
-                <a:latin typeface="Roboto"/>
-              </a:defRPr>
-            </a:pPr>
-            <a:r>
-              <a:t>  News Bureau Chief filtering global events for actionable signals</a:t>
-            </a:r>
-          </a:p>
-          <a:p>
-            <a:pPr>
-              <a:spcAft>
-                <a:spcPts val="1000"/>
-              </a:spcAft>
-              <a:defRPr sz="1600">
-                <a:solidFill>
-                  <a:srgbClr val="1E293B"/>
-                </a:solidFill>
-                <a:latin typeface="Roboto"/>
-              </a:defRPr>
-            </a:pPr>
-            <a:r>
-              <a:t>  Auto-triggered context refresh on high-impact events (score &gt;= 7)</a:t>
-            </a:r>
-          </a:p>
-          <a:p>
-            <a:pPr>
-              <a:spcAft>
-                <a:spcPts val="1000"/>
-              </a:spcAft>
-              <a:defRPr sz="1600">
-                <a:solidFill>
-                  <a:srgbClr val="1E293B"/>
-                </a:solidFill>
-                <a:latin typeface="Roboto"/>
-              </a:defRPr>
-            </a:pPr>
-            <a:r>
-              <a:t>  DataValidationEngine blocking decisions on unreliable data</a:t>
+              <a:t>Agent Network Architecture (V7)</a:t>
             </a:r>
           </a:p>
         </p:txBody>
@@ -3909,7 +3807,7 @@
               </a:defRPr>
             </a:pPr>
             <a:r>
-              <a:t>  Infrastructure: Google Cloud + N8N orchestration</a:t>
+              <a:t>  See attached XLSX: 12-month P&amp;L + Charts</a:t>
             </a:r>
           </a:p>
         </p:txBody>
@@ -3980,7 +3878,7 @@
               </a:defRPr>
             </a:pPr>
             <a:r>
-              <a:t>Growth Roadmap</a:t>
+              <a:t>Sensitivity Analysis</a:t>
             </a:r>
           </a:p>
         </p:txBody>
@@ -4019,7 +3917,7 @@
               </a:defRPr>
             </a:pPr>
             <a:r>
-              <a:t>  Q2 2026: Multi-tenant SaaS deployment</a:t>
+              <a:t>  Base Case: 74.9% margin, Month 2 break-even</a:t>
             </a:r>
           </a:p>
           <a:p>
@@ -4035,7 +3933,7 @@
               </a:defRPr>
             </a:pPr>
             <a:r>
-              <a:t>  Q3 2026: API marketplace for agent skills</a:t>
+              <a:t>  Costs +50%: Margin shrinks but remains profitable</a:t>
             </a:r>
           </a:p>
           <a:p>
@@ -4051,7 +3949,7 @@
               </a:defRPr>
             </a:pPr>
             <a:r>
-              <a:t>  Q4 2026: Enterprise compliance certification</a:t>
+              <a:t>  Costs Doubled: Still positive annual net profit</a:t>
             </a:r>
           </a:p>
           <a:p>
@@ -4067,7 +3965,23 @@
               </a:defRPr>
             </a:pPr>
             <a:r>
-              <a:t>  2027: International expansion with localized agents</a:t>
+              <a:t>  Revenue -20%: Margin compressed, breakeven delayed</a:t>
+            </a:r>
+          </a:p>
+          <a:p>
+            <a:pPr>
+              <a:spcAft>
+                <a:spcPts val="1000"/>
+              </a:spcAft>
+              <a:defRPr sz="1600">
+                <a:solidFill>
+                  <a:srgbClr val="1E293B"/>
+                </a:solidFill>
+                <a:latin typeface="Roboto"/>
+              </a:defRPr>
+            </a:pPr>
+            <a:r>
+              <a:t>  Full scenario modeling in attached spreadsheet</a:t>
             </a:r>
           </a:p>
         </p:txBody>
@@ -4081,6 +3995,164 @@
 </file>
 
 <file path=ppt/slides/slide7.xml><?xml version="1.0" encoding="utf-8"?>
+<p:sld xmlns:a="http://schemas.openxmlformats.org/drawingml/2006/main" xmlns:p="http://schemas.openxmlformats.org/presentationml/2006/main" xmlns:r="http://schemas.openxmlformats.org/officeDocument/2006/relationships">
+  <p:cSld>
+    <p:spTree>
+      <p:nvGrpSpPr>
+        <p:cNvPr id="1" name=""/>
+        <p:cNvGrpSpPr/>
+        <p:nvPr/>
+      </p:nvGrpSpPr>
+      <p:grpSpPr/>
+      <p:sp>
+        <p:nvSpPr>
+          <p:cNvPr id="2" name="Title 1"/>
+          <p:cNvSpPr>
+            <a:spLocks noGrp="1"/>
+          </p:cNvSpPr>
+          <p:nvPr>
+            <p:ph type="title"/>
+          </p:nvPr>
+        </p:nvSpPr>
+        <p:spPr/>
+        <p:txBody>
+          <a:bodyPr/>
+          <a:lstStyle/>
+          <a:p/>
+        </p:txBody>
+      </p:sp>
+      <p:sp>
+        <p:nvSpPr>
+          <p:cNvPr id="3" name="TextBox 2"/>
+          <p:cNvSpPr txBox="1"/>
+          <p:nvPr/>
+        </p:nvSpPr>
+        <p:spPr>
+          <a:xfrm>
+            <a:off x="731520" y="457200"/>
+            <a:ext cx="9144000" cy="1097280"/>
+          </a:xfrm>
+          <a:prstGeom prst="rect">
+            <a:avLst/>
+          </a:prstGeom>
+          <a:noFill/>
+        </p:spPr>
+        <p:txBody>
+          <a:bodyPr wrap="square">
+            <a:spAutoFit/>
+          </a:bodyPr>
+          <a:lstStyle/>
+          <a:p>
+            <a:pPr>
+              <a:defRPr sz="2800" b="1">
+                <a:solidFill>
+                  <a:srgbClr val="667EEA"/>
+                </a:solidFill>
+                <a:latin typeface="Inter"/>
+              </a:defRPr>
+            </a:pPr>
+            <a:r>
+              <a:t>Growth Roadmap</a:t>
+            </a:r>
+          </a:p>
+        </p:txBody>
+      </p:sp>
+      <p:sp>
+        <p:nvSpPr>
+          <p:cNvPr id="4" name="TextBox 3"/>
+          <p:cNvSpPr txBox="1"/>
+          <p:nvPr/>
+        </p:nvSpPr>
+        <p:spPr>
+          <a:xfrm>
+            <a:off x="731520" y="1645920"/>
+            <a:ext cx="9144000" cy="4114800"/>
+          </a:xfrm>
+          <a:prstGeom prst="rect">
+            <a:avLst/>
+          </a:prstGeom>
+          <a:noFill/>
+        </p:spPr>
+        <p:txBody>
+          <a:bodyPr wrap="square">
+            <a:spAutoFit/>
+          </a:bodyPr>
+          <a:lstStyle/>
+          <a:p>
+            <a:pPr>
+              <a:spcAft>
+                <a:spcPts val="1000"/>
+              </a:spcAft>
+              <a:defRPr sz="1600">
+                <a:solidFill>
+                  <a:srgbClr val="1E293B"/>
+                </a:solidFill>
+                <a:latin typeface="Roboto"/>
+              </a:defRPr>
+            </a:pPr>
+            <a:r>
+              <a:t>  Q2 2026: Multi-tenant SaaS deployment</a:t>
+            </a:r>
+          </a:p>
+          <a:p>
+            <a:pPr>
+              <a:spcAft>
+                <a:spcPts val="1000"/>
+              </a:spcAft>
+              <a:defRPr sz="1600">
+                <a:solidFill>
+                  <a:srgbClr val="1E293B"/>
+                </a:solidFill>
+                <a:latin typeface="Roboto"/>
+              </a:defRPr>
+            </a:pPr>
+            <a:r>
+              <a:t>  Q3 2026: API marketplace for agent skills</a:t>
+            </a:r>
+          </a:p>
+          <a:p>
+            <a:pPr>
+              <a:spcAft>
+                <a:spcPts val="1000"/>
+              </a:spcAft>
+              <a:defRPr sz="1600">
+                <a:solidFill>
+                  <a:srgbClr val="1E293B"/>
+                </a:solidFill>
+                <a:latin typeface="Roboto"/>
+              </a:defRPr>
+            </a:pPr>
+            <a:r>
+              <a:t>  Q4 2026: Enterprise compliance certification</a:t>
+            </a:r>
+          </a:p>
+          <a:p>
+            <a:pPr>
+              <a:spcAft>
+                <a:spcPts val="1000"/>
+              </a:spcAft>
+              <a:defRPr sz="1600">
+                <a:solidFill>
+                  <a:srgbClr val="1E293B"/>
+                </a:solidFill>
+                <a:latin typeface="Roboto"/>
+              </a:defRPr>
+            </a:pPr>
+            <a:r>
+              <a:t>  2027: International expansion</a:t>
+            </a:r>
+          </a:p>
+        </p:txBody>
+      </p:sp>
+    </p:spTree>
+  </p:cSld>
+  <p:clrMapOvr>
+    <a:masterClrMapping/>
+  </p:clrMapOvr>
+</p:sld>
+</file>
+
+<file path=ppt/slides/slide8.xml><?xml version="1.0" encoding="utf-8"?>
 <p:sld xmlns:a="http://schemas.openxmlformats.org/drawingml/2006/main" xmlns:p="http://schemas.openxmlformats.org/presentationml/2006/main" xmlns:r="http://schemas.openxmlformats.org/officeDocument/2006/relationships">
   <p:cSld>
     <p:spTree>

</xml_diff>